<commit_message>
fix: strip local file paths from presentation metadata
Image alt-text was defaulting to the source screenshot's absolute path
on my machine. Set explicit alt text instead, and ignore Office lock
files going forward.
</commit_message>
<xml_diff>
--- a/presentation/EPPB_presentation.pptx
+++ b/presentation/EPPB_presentation.pptx
@@ -3739,7 +3739,7 @@
       </p:sp>
       <p:pic>
         <p:nvPicPr>
-          <p:cNvPr id="5" name="Image 0" descr="/private/tmp/claude-501/-Users-roomi-Desktop-TS-AI-Bootcamp-wine-pca-analysis/3023ee90-6fc7-482c-ab74-fc26da634abc/scratchpad/shots/10-analytics.png">    </p:cNvPr>
+          <p:cNvPr id="5" name="Image 0" descr="[object Object]">    </p:cNvPr>
           <p:cNvPicPr>
             <a:picLocks noChangeAspect="1"/>
           </p:cNvPicPr>
@@ -4070,7 +4070,7 @@
       </p:sp>
       <p:pic>
         <p:nvPicPr>
-          <p:cNvPr id="5" name="Image 0" descr="/private/tmp/claude-501/-Users-roomi-Desktop-TS-AI-Bootcamp-wine-pca-analysis/3023ee90-6fc7-482c-ab74-fc26da634abc/scratchpad/shots/09-map.png">    </p:cNvPr>
+          <p:cNvPr id="5" name="Image 0" descr="[object Object]">    </p:cNvPr>
           <p:cNvPicPr>
             <a:picLocks noChangeAspect="1"/>
           </p:cNvPicPr>
@@ -4422,7 +4422,7 @@
       </p:sp>
       <p:pic>
         <p:nvPicPr>
-          <p:cNvPr id="5" name="Image 0" descr="/private/tmp/claude-501/-Users-roomi-Desktop-TS-AI-Bootcamp-wine-pca-analysis/3023ee90-6fc7-482c-ab74-fc26da634abc/scratchpad/shots/11-tools.png">    </p:cNvPr>
+          <p:cNvPr id="5" name="Image 0" descr="[object Object]">    </p:cNvPr>
           <p:cNvPicPr>
             <a:picLocks noChangeAspect="1"/>
           </p:cNvPicPr>
@@ -10462,7 +10462,7 @@
       </p:sp>
       <p:pic>
         <p:nvPicPr>
-          <p:cNvPr id="5" name="Image 0" descr="/private/tmp/claude-501/-Users-roomi-Desktop-TS-AI-Bootcamp-wine-pca-analysis/3023ee90-6fc7-482c-ab74-fc26da634abc/scratchpad/shots/01-home.png">    </p:cNvPr>
+          <p:cNvPr id="5" name="Image 0" descr="[object Object]">    </p:cNvPr>
           <p:cNvPicPr>
             <a:picLocks noChangeAspect="1"/>
           </p:cNvPicPr>
@@ -10814,7 +10814,7 @@
       </p:sp>
       <p:pic>
         <p:nvPicPr>
-          <p:cNvPr id="5" name="Image 0" descr="/private/tmp/claude-501/-Users-roomi-Desktop-TS-AI-Bootcamp-wine-pca-analysis/3023ee90-6fc7-482c-ab74-fc26da634abc/scratchpad/shots/02-catalog.png">    </p:cNvPr>
+          <p:cNvPr id="5" name="Image 0" descr="[object Object]">    </p:cNvPr>
           <p:cNvPicPr>
             <a:picLocks noChangeAspect="1"/>
           </p:cNvPicPr>
@@ -10872,7 +10872,7 @@
       </p:sp>
       <p:pic>
         <p:nvPicPr>
-          <p:cNvPr id="7" name="Image 1" descr="/private/tmp/claude-501/-Users-roomi-Desktop-TS-AI-Bootcamp-wine-pca-analysis/3023ee90-6fc7-482c-ab74-fc26da634abc/scratchpad/shots/03-service-card.png">    </p:cNvPr>
+          <p:cNvPr id="7" name="Image 1" descr="[object Object]">    </p:cNvPr>
           <p:cNvPicPr>
             <a:picLocks noChangeAspect="1"/>
           </p:cNvPicPr>
@@ -11203,7 +11203,7 @@
       </p:sp>
       <p:pic>
         <p:nvPicPr>
-          <p:cNvPr id="5" name="Image 0" descr="/private/tmp/claude-501/-Users-roomi-Desktop-TS-AI-Bootcamp-wine-pca-analysis/3023ee90-6fc7-482c-ab74-fc26da634abc/scratchpad/shots/08-admin-constructor.png">    </p:cNvPr>
+          <p:cNvPr id="5" name="Image 0" descr="[object Object]">    </p:cNvPr>
           <p:cNvPicPr>
             <a:picLocks noChangeAspect="1"/>
           </p:cNvPicPr>
@@ -11576,7 +11576,7 @@
       </p:sp>
       <p:pic>
         <p:nvPicPr>
-          <p:cNvPr id="5" name="Image 0" descr="/private/tmp/claude-501/-Users-roomi-Desktop-TS-AI-Bootcamp-wine-pca-analysis/3023ee90-6fc7-482c-ab74-fc26da634abc/scratchpad/shots/04-wizard-step1.png">    </p:cNvPr>
+          <p:cNvPr id="5" name="Image 0" descr="[object Object]">    </p:cNvPr>
           <p:cNvPicPr>
             <a:picLocks noChangeAspect="1"/>
           </p:cNvPicPr>
@@ -11634,7 +11634,7 @@
       </p:sp>
       <p:pic>
         <p:nvPicPr>
-          <p:cNvPr id="7" name="Image 1" descr="/private/tmp/claude-501/-Users-roomi-Desktop-TS-AI-Bootcamp-wine-pca-analysis/3023ee90-6fc7-482c-ab74-fc26da634abc/scratchpad/shots/05-wizard-step2.png">    </p:cNvPr>
+          <p:cNvPr id="7" name="Image 1" descr="[object Object]">    </p:cNvPr>
           <p:cNvPicPr>
             <a:picLocks noChangeAspect="1"/>
           </p:cNvPicPr>
@@ -11986,7 +11986,7 @@
       </p:sp>
       <p:pic>
         <p:nvPicPr>
-          <p:cNvPr id="5" name="Image 0" descr="/private/tmp/claude-501/-Users-roomi-Desktop-TS-AI-Bootcamp-wine-pca-analysis/3023ee90-6fc7-482c-ab74-fc26da634abc/scratchpad/shots/06-cabinet.png">    </p:cNvPr>
+          <p:cNvPr id="5" name="Image 0" descr="[object Object]">    </p:cNvPr>
           <p:cNvPicPr>
             <a:picLocks noChangeAspect="1"/>
           </p:cNvPicPr>

</xml_diff>